<commit_message>
Fill student details and refresh submission assets
</commit_message>
<xml_diff>
--- a/presentation/Urban_Climate_Insights_API_Presentation.pptx
+++ b/presentation/Urban_Climate_Insights_API_Presentation.pptx
@@ -3249,7 +3249,7 @@
               </a:defRPr>
             </a:pPr>
             <a:r>
-              <a:t>Student Name: [Fill Before Submission]</a:t>
+              <a:t>Student Name: Yuan Rui</a:t>
             </a:r>
           </a:p>
         </p:txBody>
@@ -3284,7 +3284,7 @@
               </a:defRPr>
             </a:pPr>
             <a:r>
-              <a:t>Student ID: [Fill Before Submission]</a:t>
+              <a:t>Student ID: 2022115981</a:t>
             </a:r>
           </a:p>
         </p:txBody>
@@ -3319,7 +3319,7 @@
               </a:defRPr>
             </a:pPr>
             <a:r>
-              <a:t>GitHub: [Public Repository URL]</a:t>
+              <a:t>GitHub: https://github.com/gapmaker1/urban-climate-insights-api</a:t>
             </a:r>
           </a:p>
         </p:txBody>
@@ -4630,6 +4630,21 @@
             </a:pPr>
             <a:r>
               <a:t>Pytest covers authentication, CRUD, and analytics behaviour.</a:t>
+            </a:r>
+          </a:p>
+          <a:p>
+            <a:pPr>
+              <a:spcAft>
+                <a:spcPts val="1000"/>
+              </a:spcAft>
+              <a:defRPr sz="1900">
+                <a:solidFill>
+                  <a:srgbClr val="0F172A"/>
+                </a:solidFill>
+              </a:defRPr>
+            </a:pPr>
+            <a:r>
+              <a:t>Technical report highlights stack choice, testing, limitations, and declared GenAI usage.</a:t>
             </a:r>
           </a:p>
           <a:p>

</xml_diff>

<commit_message>
Finalize report links and presentation submission content
</commit_message>
<xml_diff>
--- a/presentation/Urban_Climate_Insights_API_Presentation.pptx
+++ b/presentation/Urban_Climate_Insights_API_Presentation.pptx
@@ -8288,51 +8288,8 @@
           </a:bodyPr>
           <a:lstStyle/>
           <a:p>
-            <a:pPr>
-              <a:spcAft>
-                <a:spcPts val="800"/>
-              </a:spcAft>
-              <a:defRPr sz="1400">
-                <a:solidFill>
-                  <a:srgbClr val="0F172A"/>
-                </a:solidFill>
-                <a:latin typeface="Aptos"/>
-              </a:defRPr>
-            </a:pPr>
-            <a:r>
-              <a:t>Public GitHub repo</a:t>
-            </a:r>
-          </a:p>
-          <a:p>
-            <a:pPr>
-              <a:spcAft>
-                <a:spcPts val="800"/>
-              </a:spcAft>
-              <a:defRPr sz="1400">
-                <a:solidFill>
-                  <a:srgbClr val="0F172A"/>
-                </a:solidFill>
-                <a:latin typeface="Aptos"/>
-              </a:defRPr>
-            </a:pPr>
-            <a:r>
-              <a:t>Visible commit history</a:t>
-            </a:r>
-          </a:p>
-          <a:p>
-            <a:pPr>
-              <a:spcAft>
-                <a:spcPts val="800"/>
-              </a:spcAft>
-              <a:defRPr sz="1400">
-                <a:solidFill>
-                  <a:srgbClr val="0F172A"/>
-                </a:solidFill>
-                <a:latin typeface="Aptos"/>
-              </a:defRPr>
-            </a:pPr>
-            <a:r>
-              <a:t>Runnable project state</a:t>
+            <a:r>
+              <a:t>Public GitHub repo | Commit history: setup, core API, tests, docs, cleanup | Runnable final version</a:t>
             </a:r>
           </a:p>
         </p:txBody>
@@ -8404,22 +8361,9 @@
           </a:bodyPr>
           <a:lstStyle/>
           <a:p>
-            <a:pPr algn="l"/>
-            <a:r>
-              <a:rPr sz="2000" b="1">
-                <a:solidFill>
-                  <a:srgbClr val="0F172A"/>
-                </a:solidFill>
-                <a:latin typeface="Aptos Display"/>
-              </a:rPr>
-              <a:t>API Documentation</a:t>
-            </a:r>
-            <a:endParaRPr sz="2000" b="1">
-              <a:solidFill>
-                <a:srgbClr val="0F172A"/>
-              </a:solidFill>
-              <a:latin typeface="Aptos Display"/>
-            </a:endParaRPr>
+            <a:r>
+              <a:t>API Documentation Overview</a:t>
+            </a:r>
           </a:p>
         </p:txBody>
       </p:sp>
@@ -8561,22 +8505,9 @@
           </a:bodyPr>
           <a:lstStyle/>
           <a:p>
-            <a:pPr algn="l"/>
-            <a:r>
-              <a:rPr sz="2000" b="1">
-                <a:solidFill>
-                  <a:srgbClr val="0F172A"/>
-                </a:solidFill>
-                <a:latin typeface="Aptos Display"/>
-              </a:rPr>
-              <a:t>Technical Report</a:t>
-            </a:r>
-            <a:endParaRPr sz="2000" b="1">
-              <a:solidFill>
-                <a:srgbClr val="0F172A"/>
-              </a:solidFill>
-              <a:latin typeface="Aptos Display"/>
-            </a:endParaRPr>
+            <a:r>
+              <a:t>Technical Report Highlights</a:t>
+            </a:r>
           </a:p>
         </p:txBody>
       </p:sp>
@@ -8602,51 +8533,8 @@
           </a:bodyPr>
           <a:lstStyle/>
           <a:p>
-            <a:pPr>
-              <a:spcAft>
-                <a:spcPts val="800"/>
-              </a:spcAft>
-              <a:defRPr sz="1400">
-                <a:solidFill>
-                  <a:srgbClr val="0F172A"/>
-                </a:solidFill>
-                <a:latin typeface="Aptos"/>
-              </a:defRPr>
-            </a:pPr>
-            <a:r>
-              <a:t>Stack justification</a:t>
-            </a:r>
-          </a:p>
-          <a:p>
-            <a:pPr>
-              <a:spcAft>
-                <a:spcPts val="800"/>
-              </a:spcAft>
-              <a:defRPr sz="1400">
-                <a:solidFill>
-                  <a:srgbClr val="0F172A"/>
-                </a:solidFill>
-                <a:latin typeface="Aptos"/>
-              </a:defRPr>
-            </a:pPr>
-            <a:r>
-              <a:t>Testing + limitations</a:t>
-            </a:r>
-          </a:p>
-          <a:p>
-            <a:pPr>
-              <a:spcAft>
-                <a:spcPts val="800"/>
-              </a:spcAft>
-              <a:defRPr sz="1400">
-                <a:solidFill>
-                  <a:srgbClr val="0F172A"/>
-                </a:solidFill>
-                <a:latin typeface="Aptos"/>
-              </a:defRPr>
-            </a:pPr>
-            <a:r>
-              <a:t>GenAI declaration</a:t>
+            <a:r>
+              <a:t>Stack justification | Architecture and testing approach | Limitations, future work, and GenAI declaration</a:t>
             </a:r>
           </a:p>
         </p:txBody>
@@ -8875,22 +8763,9 @@
           </a:bodyPr>
           <a:lstStyle/>
           <a:p>
-            <a:pPr algn="l"/>
-            <a:r>
-              <a:rPr sz="2000" b="1">
-                <a:solidFill>
-                  <a:srgbClr val="0F172A"/>
-                </a:solidFill>
-                <a:latin typeface="Aptos Display"/>
-              </a:rPr>
-              <a:t>Deliverables included</a:t>
-            </a:r>
-            <a:endParaRPr sz="2000" b="1">
-              <a:solidFill>
-                <a:srgbClr val="0F172A"/>
-              </a:solidFill>
-              <a:latin typeface="Aptos Display"/>
-            </a:endParaRPr>
+            <a:r>
+              <a:t>All Deliverables</a:t>
+            </a:r>
           </a:p>
         </p:txBody>
       </p:sp>
@@ -8916,19 +8791,8 @@
           </a:bodyPr>
           <a:lstStyle/>
           <a:p>
-            <a:pPr>
-              <a:spcAft>
-                <a:spcPts val="800"/>
-              </a:spcAft>
-              <a:defRPr sz="1500">
-                <a:solidFill>
-                  <a:srgbClr val="0F172A"/>
-                </a:solidFill>
-                <a:latin typeface="Aptos"/>
-              </a:defRPr>
-            </a:pPr>
-            <a:r>
-              <a:t>README, API documentation PDF, technical report PDF, OpenAPI schema export, presentation deck, and reproducible seed script.</a:t>
+            <a:r>
+              <a:t>Code repository, API documentation PDF, technical report PDF, presentation slides, OpenAPI export, and reproducible seed script.</a:t>
             </a:r>
           </a:p>
         </p:txBody>

</xml_diff>